<commit_message>
Ajouter le nom de l'autrice sur le rendu d'étape 1
Co-Authored-By: Claude Opus 5.5 <noreply@anthropic.com>
</commit_message>
<xml_diff>
--- a/presentation/rendu_etape_1.pptx
+++ b/presentation/rendu_etape_1.pptx
@@ -2432,8 +2432,8 @@
         </p:nvSpPr>
         <p:spPr>
           <a:xfrm>
-            <a:off x="548640" y="3749040"/>
-            <a:ext cx="8046720" cy="640080"/>
+            <a:off x="548640" y="3566160"/>
+            <a:ext cx="8046720" cy="914400"/>
           </a:xfrm>
           <a:prstGeom prst="rect">
             <a:avLst/>
@@ -2444,6 +2444,23 @@
         <p:txBody>
           <a:bodyPr wrap="square" lIns="0" tIns="0" rIns="0" bIns="0" rtlCol="0" anchor="ctr"/>
           <a:lstStyle/>
+          <a:p>
+            <a:pPr indent="0" marL="0">
+              <a:buNone/>
+            </a:pPr>
+            <a:r>
+              <a:rPr lang="en-US" sz="1400" b="1" dirty="0">
+                <a:solidFill>
+                  <a:srgbClr val="FFFFFF"/>
+                </a:solidFill>
+                <a:latin typeface="Calibri" pitchFamily="34" charset="0"/>
+                <a:ea typeface="Calibri" pitchFamily="34" charset="-122"/>
+                <a:cs typeface="Calibri" pitchFamily="34" charset="-120"/>
+              </a:rPr>
+              <a:t>Salma Bouhmid</a:t>
+            </a:r>
+            <a:endParaRPr lang="en-US" sz="1400" dirty="0"/>
+          </a:p>
           <a:p>
             <a:pPr indent="0" marL="0">
               <a:buNone/>

</xml_diff>